<commit_message>
Add 正反合 synthesis slide with f1-f4 evolution diagram
</commit_message>
<xml_diff>
--- a/T公司AI应用软件技术成果转化策略研究_开题汇报.pptx
+++ b/T公司AI应用软件技术成果转化策略研究_开题汇报.pptx
@@ -16,6 +16,7 @@
     <p:sldId id="264" r:id="rId15"/>
     <p:sldId id="265" r:id="rId16"/>
     <p:sldId id="266" r:id="rId17"/>
+    <p:sldId id="267" r:id="rId18"/>
   </p:sldIdLst>
   <p:sldSz cx="12191695" cy="6858000" type="screen4x3"/>
   <p:notesSz cx="6858000" cy="9144000"/>
@@ -4672,7 +4673,6 @@
           </a:bodyPr>
           <a:lstStyle/>
           <a:p>
-            <a:pPr/>
             <a:r>
               <a:rPr sz="1200">
                 <a:solidFill>
@@ -4684,7 +4684,6 @@
             </a:r>
           </a:p>
           <a:p>
-            <a:pPr/>
             <a:r>
               <a:rPr sz="1200">
                 <a:solidFill>
@@ -4696,7 +4695,6 @@
             </a:r>
           </a:p>
           <a:p>
-            <a:pPr/>
             <a:r>
               <a:rPr sz="1200">
                 <a:solidFill>
@@ -4777,7 +4775,7 @@
             <a:avLst/>
           </a:prstGeom>
           <a:solidFill>
-            <a:srgbClr val="F2F7FD"/>
+            <a:srgbClr val="F5F8FC"/>
           </a:solidFill>
           <a:ln>
             <a:noFill/>
@@ -4852,7 +4850,7 @@
                 </a:solidFill>
                 <a:latin typeface="Microsoft YaHei"/>
               </a:rPr>
-              <a:t>十、汇报总结</a:t>
+              <a:t>十、研究核心逻辑：正—反—合</a:t>
             </a:r>
           </a:p>
           <a:p>
@@ -4863,21 +4861,696 @@
                 </a:solidFill>
                 <a:latin typeface="Microsoft YaHei"/>
               </a:rPr>
-              <a:t>选题聚焦明确、问题导向清晰、策略框架可落地</a:t>
-            </a:r>
-          </a:p>
-        </p:txBody>
-      </p:sp>
-      <p:sp>
-        <p:nvSpPr>
-          <p:cNvPr id="4" name="Rounded Rectangle 3"/>
+              <a:t>T公司AI应用软件成果转化路径总览 · 推动从f2穿越绿色区间迈向f3</a:t>
+            </a:r>
+          </a:p>
+        </p:txBody>
+      </p:sp>
+      <p:sp>
+        <p:nvSpPr>
+          <p:cNvPr id="4" name="Oval 3"/>
           <p:cNvSpPr/>
           <p:nvPr/>
         </p:nvSpPr>
         <p:spPr>
           <a:xfrm>
-            <a:off x="914400" y="1143000"/>
-            <a:ext cx="10332720" cy="1005840"/>
+            <a:off x="4187952" y="822960"/>
+            <a:ext cx="3602736" cy="1499616"/>
+          </a:xfrm>
+          <a:prstGeom prst="ellipse">
+            <a:avLst/>
+          </a:prstGeom>
+          <a:solidFill>
+            <a:srgbClr val="C6E5BE"/>
+          </a:solidFill>
+          <a:ln w="19050">
+            <a:solidFill>
+              <a:srgbClr val="46963C"/>
+            </a:solidFill>
+          </a:ln>
+        </p:spPr>
+        <p:style>
+          <a:lnRef idx="1">
+            <a:schemeClr val="accent1"/>
+          </a:lnRef>
+          <a:fillRef idx="3">
+            <a:schemeClr val="accent1"/>
+          </a:fillRef>
+          <a:effectRef idx="2">
+            <a:schemeClr val="accent1"/>
+          </a:effectRef>
+          <a:fontRef idx="minor">
+            <a:schemeClr val="lt1"/>
+          </a:fontRef>
+        </p:style>
+        <p:txBody>
+          <a:bodyPr rtlCol="0" anchor="ctr"/>
+          <a:lstStyle/>
+          <a:p>
+            <a:pPr algn="ctr"/>
+          </a:p>
+        </p:txBody>
+      </p:sp>
+      <p:sp>
+        <p:nvSpPr>
+          <p:cNvPr id="5" name="Oval 4"/>
+          <p:cNvSpPr/>
+          <p:nvPr/>
+        </p:nvSpPr>
+        <p:spPr>
+          <a:xfrm>
+            <a:off x="1353312" y="777240"/>
+            <a:ext cx="9317736" cy="1591056"/>
+          </a:xfrm>
+          <a:prstGeom prst="ellipse">
+            <a:avLst/>
+          </a:prstGeom>
+          <a:noFill/>
+          <a:ln w="25400">
+            <a:solidFill>
+              <a:srgbClr val="1F2937"/>
+            </a:solidFill>
+          </a:ln>
+        </p:spPr>
+        <p:style>
+          <a:lnRef idx="1">
+            <a:schemeClr val="accent1"/>
+          </a:lnRef>
+          <a:fillRef idx="3">
+            <a:schemeClr val="accent1"/>
+          </a:fillRef>
+          <a:effectRef idx="2">
+            <a:schemeClr val="accent1"/>
+          </a:effectRef>
+          <a:fontRef idx="minor">
+            <a:schemeClr val="lt1"/>
+          </a:fontRef>
+        </p:style>
+        <p:txBody>
+          <a:bodyPr rtlCol="0" anchor="ctr"/>
+          <a:lstStyle/>
+          <a:p>
+            <a:pPr algn="ctr"/>
+          </a:p>
+        </p:txBody>
+      </p:sp>
+      <p:sp>
+        <p:nvSpPr>
+          <p:cNvPr id="6" name="Oval 5"/>
+          <p:cNvSpPr/>
+          <p:nvPr/>
+        </p:nvSpPr>
+        <p:spPr>
+          <a:xfrm>
+            <a:off x="1408176" y="822960"/>
+            <a:ext cx="2944368" cy="1499616"/>
+          </a:xfrm>
+          <a:prstGeom prst="ellipse">
+            <a:avLst/>
+          </a:prstGeom>
+          <a:noFill/>
+          <a:ln w="22860">
+            <a:solidFill>
+              <a:srgbClr val="1F2937"/>
+            </a:solidFill>
+          </a:ln>
+        </p:spPr>
+        <p:style>
+          <a:lnRef idx="1">
+            <a:schemeClr val="accent1"/>
+          </a:lnRef>
+          <a:fillRef idx="3">
+            <a:schemeClr val="accent1"/>
+          </a:fillRef>
+          <a:effectRef idx="2">
+            <a:schemeClr val="accent1"/>
+          </a:effectRef>
+          <a:fontRef idx="minor">
+            <a:schemeClr val="lt1"/>
+          </a:fontRef>
+        </p:style>
+        <p:txBody>
+          <a:bodyPr rtlCol="0" anchor="ctr"/>
+          <a:lstStyle/>
+          <a:p>
+            <a:pPr algn="ctr"/>
+          </a:p>
+        </p:txBody>
+      </p:sp>
+      <p:sp>
+        <p:nvSpPr>
+          <p:cNvPr id="7" name="Oval 6"/>
+          <p:cNvSpPr/>
+          <p:nvPr/>
+        </p:nvSpPr>
+        <p:spPr>
+          <a:xfrm>
+            <a:off x="7626096" y="822960"/>
+            <a:ext cx="2990088" cy="1499616"/>
+          </a:xfrm>
+          <a:prstGeom prst="ellipse">
+            <a:avLst/>
+          </a:prstGeom>
+          <a:noFill/>
+          <a:ln w="22860">
+            <a:solidFill>
+              <a:srgbClr val="1F2937"/>
+            </a:solidFill>
+          </a:ln>
+        </p:spPr>
+        <p:style>
+          <a:lnRef idx="1">
+            <a:schemeClr val="accent1"/>
+          </a:lnRef>
+          <a:fillRef idx="3">
+            <a:schemeClr val="accent1"/>
+          </a:fillRef>
+          <a:effectRef idx="2">
+            <a:schemeClr val="accent1"/>
+          </a:effectRef>
+          <a:fontRef idx="minor">
+            <a:schemeClr val="lt1"/>
+          </a:fontRef>
+        </p:style>
+        <p:txBody>
+          <a:bodyPr rtlCol="0" anchor="ctr"/>
+          <a:lstStyle/>
+          <a:p>
+            <a:pPr algn="ctr"/>
+          </a:p>
+        </p:txBody>
+      </p:sp>
+      <p:cxnSp>
+        <p:nvCxnSpPr>
+          <p:cNvPr id="8" name="Connector 7"/>
+          <p:cNvCxnSpPr/>
+          <p:nvPr/>
+        </p:nvCxnSpPr>
+        <p:spPr>
+          <a:xfrm>
+            <a:off x="502920" y="1572768"/>
+            <a:ext cx="10789920" cy="0"/>
+          </a:xfrm>
+          <a:prstGeom prst="line">
+            <a:avLst/>
+          </a:prstGeom>
+          <a:ln w="31750">
+            <a:solidFill>
+              <a:srgbClr val="1F2937"/>
+            </a:solidFill>
+            <a:headEnd type="arrow" w="med" len="med"/>
+          </a:ln>
+        </p:spPr>
+        <p:style>
+          <a:lnRef idx="2">
+            <a:schemeClr val="accent1"/>
+          </a:lnRef>
+          <a:fillRef idx="0">
+            <a:schemeClr val="accent1"/>
+          </a:fillRef>
+          <a:effectRef idx="1">
+            <a:schemeClr val="accent1"/>
+          </a:effectRef>
+          <a:fontRef idx="minor">
+            <a:schemeClr val="tx1"/>
+          </a:fontRef>
+        </p:style>
+      </p:cxnSp>
+      <p:sp>
+        <p:nvSpPr>
+          <p:cNvPr id="9" name="TextBox 8"/>
+          <p:cNvSpPr txBox="1"/>
+          <p:nvPr/>
+        </p:nvSpPr>
+        <p:spPr>
+          <a:xfrm>
+            <a:off x="11018520" y="1325880"/>
+            <a:ext cx="1097280" cy="237744"/>
+          </a:xfrm>
+          <a:prstGeom prst="rect">
+            <a:avLst/>
+          </a:prstGeom>
+          <a:noFill/>
+        </p:spPr>
+        <p:txBody>
+          <a:bodyPr wrap="square" anchor="t">
+            <a:noAutofit/>
+          </a:bodyPr>
+          <a:lstStyle/>
+          <a:p>
+            <a:pPr algn="l"/>
+            <a:r>
+              <a:rPr sz="1300" b="1">
+                <a:solidFill>
+                  <a:srgbClr val="1F2937"/>
+                </a:solidFill>
+                <a:latin typeface="Microsoft YaHei"/>
+              </a:rPr>
+              <a:t>Business</a:t>
+            </a:r>
+          </a:p>
+        </p:txBody>
+      </p:sp>
+      <p:sp>
+        <p:nvSpPr>
+          <p:cNvPr id="10" name="Oval 9"/>
+          <p:cNvSpPr/>
+          <p:nvPr/>
+        </p:nvSpPr>
+        <p:spPr>
+          <a:xfrm>
+            <a:off x="1234440" y="1344168"/>
+            <a:ext cx="457200" cy="457200"/>
+          </a:xfrm>
+          <a:prstGeom prst="ellipse">
+            <a:avLst/>
+          </a:prstGeom>
+          <a:solidFill>
+            <a:srgbClr val="FFFFFF"/>
+          </a:solidFill>
+          <a:ln w="25400">
+            <a:solidFill>
+              <a:srgbClr val="1F2937"/>
+            </a:solidFill>
+          </a:ln>
+        </p:spPr>
+        <p:style>
+          <a:lnRef idx="1">
+            <a:schemeClr val="accent1"/>
+          </a:lnRef>
+          <a:fillRef idx="3">
+            <a:schemeClr val="accent1"/>
+          </a:fillRef>
+          <a:effectRef idx="2">
+            <a:schemeClr val="accent1"/>
+          </a:effectRef>
+          <a:fontRef idx="minor">
+            <a:schemeClr val="lt1"/>
+          </a:fontRef>
+        </p:style>
+        <p:txBody>
+          <a:bodyPr rtlCol="0" anchor="ctr"/>
+          <a:lstStyle/>
+          <a:p>
+            <a:pPr algn="ctr"/>
+            <a:r>
+              <a:rPr sz="1500" b="1">
+                <a:solidFill>
+                  <a:srgbClr val="1F2937"/>
+                </a:solidFill>
+                <a:latin typeface="Microsoft YaHei"/>
+              </a:rPr>
+              <a:t>f1</a:t>
+            </a:r>
+          </a:p>
+        </p:txBody>
+      </p:sp>
+      <p:sp>
+        <p:nvSpPr>
+          <p:cNvPr id="11" name="Oval 10"/>
+          <p:cNvSpPr/>
+          <p:nvPr/>
+        </p:nvSpPr>
+        <p:spPr>
+          <a:xfrm>
+            <a:off x="4069080" y="1344168"/>
+            <a:ext cx="457200" cy="457200"/>
+          </a:xfrm>
+          <a:prstGeom prst="ellipse">
+            <a:avLst/>
+          </a:prstGeom>
+          <a:solidFill>
+            <a:srgbClr val="FFFFFF"/>
+          </a:solidFill>
+          <a:ln w="25400">
+            <a:solidFill>
+              <a:srgbClr val="1F2937"/>
+            </a:solidFill>
+          </a:ln>
+        </p:spPr>
+        <p:style>
+          <a:lnRef idx="1">
+            <a:schemeClr val="accent1"/>
+          </a:lnRef>
+          <a:fillRef idx="3">
+            <a:schemeClr val="accent1"/>
+          </a:fillRef>
+          <a:effectRef idx="2">
+            <a:schemeClr val="accent1"/>
+          </a:effectRef>
+          <a:fontRef idx="minor">
+            <a:schemeClr val="lt1"/>
+          </a:fontRef>
+        </p:style>
+        <p:txBody>
+          <a:bodyPr rtlCol="0" anchor="ctr"/>
+          <a:lstStyle/>
+          <a:p>
+            <a:pPr algn="ctr"/>
+            <a:r>
+              <a:rPr sz="1500" b="1">
+                <a:solidFill>
+                  <a:srgbClr val="1F2937"/>
+                </a:solidFill>
+                <a:latin typeface="Microsoft YaHei"/>
+              </a:rPr>
+              <a:t>f2</a:t>
+            </a:r>
+          </a:p>
+        </p:txBody>
+      </p:sp>
+      <p:sp>
+        <p:nvSpPr>
+          <p:cNvPr id="12" name="Oval 11"/>
+          <p:cNvSpPr/>
+          <p:nvPr/>
+        </p:nvSpPr>
+        <p:spPr>
+          <a:xfrm>
+            <a:off x="7452360" y="1344168"/>
+            <a:ext cx="457200" cy="457200"/>
+          </a:xfrm>
+          <a:prstGeom prst="ellipse">
+            <a:avLst/>
+          </a:prstGeom>
+          <a:solidFill>
+            <a:srgbClr val="FFFFFF"/>
+          </a:solidFill>
+          <a:ln w="25400">
+            <a:solidFill>
+              <a:srgbClr val="1F2937"/>
+            </a:solidFill>
+          </a:ln>
+        </p:spPr>
+        <p:style>
+          <a:lnRef idx="1">
+            <a:schemeClr val="accent1"/>
+          </a:lnRef>
+          <a:fillRef idx="3">
+            <a:schemeClr val="accent1"/>
+          </a:fillRef>
+          <a:effectRef idx="2">
+            <a:schemeClr val="accent1"/>
+          </a:effectRef>
+          <a:fontRef idx="minor">
+            <a:schemeClr val="lt1"/>
+          </a:fontRef>
+        </p:style>
+        <p:txBody>
+          <a:bodyPr rtlCol="0" anchor="ctr"/>
+          <a:lstStyle/>
+          <a:p>
+            <a:pPr algn="ctr"/>
+            <a:r>
+              <a:rPr sz="1500" b="1">
+                <a:solidFill>
+                  <a:srgbClr val="1F2937"/>
+                </a:solidFill>
+                <a:latin typeface="Microsoft YaHei"/>
+              </a:rPr>
+              <a:t>f3</a:t>
+            </a:r>
+          </a:p>
+        </p:txBody>
+      </p:sp>
+      <p:sp>
+        <p:nvSpPr>
+          <p:cNvPr id="13" name="Oval 12"/>
+          <p:cNvSpPr/>
+          <p:nvPr/>
+        </p:nvSpPr>
+        <p:spPr>
+          <a:xfrm>
+            <a:off x="10332720" y="1344168"/>
+            <a:ext cx="457200" cy="457200"/>
+          </a:xfrm>
+          <a:prstGeom prst="ellipse">
+            <a:avLst/>
+          </a:prstGeom>
+          <a:solidFill>
+            <a:srgbClr val="FFFFFF"/>
+          </a:solidFill>
+          <a:ln w="25400">
+            <a:solidFill>
+              <a:srgbClr val="1F2937"/>
+            </a:solidFill>
+          </a:ln>
+        </p:spPr>
+        <p:style>
+          <a:lnRef idx="1">
+            <a:schemeClr val="accent1"/>
+          </a:lnRef>
+          <a:fillRef idx="3">
+            <a:schemeClr val="accent1"/>
+          </a:fillRef>
+          <a:effectRef idx="2">
+            <a:schemeClr val="accent1"/>
+          </a:effectRef>
+          <a:fontRef idx="minor">
+            <a:schemeClr val="lt1"/>
+          </a:fontRef>
+        </p:style>
+        <p:txBody>
+          <a:bodyPr rtlCol="0" anchor="ctr"/>
+          <a:lstStyle/>
+          <a:p>
+            <a:pPr algn="ctr"/>
+            <a:r>
+              <a:rPr sz="1500" b="1">
+                <a:solidFill>
+                  <a:srgbClr val="1F2937"/>
+                </a:solidFill>
+                <a:latin typeface="Microsoft YaHei"/>
+              </a:rPr>
+              <a:t>f4</a:t>
+            </a:r>
+          </a:p>
+        </p:txBody>
+      </p:sp>
+      <p:sp>
+        <p:nvSpPr>
+          <p:cNvPr id="14" name="TextBox 13"/>
+          <p:cNvSpPr txBox="1"/>
+          <p:nvPr/>
+        </p:nvSpPr>
+        <p:spPr>
+          <a:xfrm>
+            <a:off x="4480560" y="868680"/>
+            <a:ext cx="3017520" cy="292608"/>
+          </a:xfrm>
+          <a:prstGeom prst="rect">
+            <a:avLst/>
+          </a:prstGeom>
+          <a:noFill/>
+        </p:spPr>
+        <p:txBody>
+          <a:bodyPr wrap="square" anchor="t">
+            <a:noAutofit/>
+          </a:bodyPr>
+          <a:lstStyle/>
+          <a:p>
+            <a:pPr algn="ctr"/>
+            <a:r>
+              <a:rPr sz="1400" b="1">
+                <a:solidFill>
+                  <a:srgbClr val="196E19"/>
+                </a:solidFill>
+                <a:latin typeface="Microsoft YaHei"/>
+              </a:rPr>
+              <a:t>AI应用成果转化</a:t>
+            </a:r>
+          </a:p>
+        </p:txBody>
+      </p:sp>
+      <p:sp>
+        <p:nvSpPr>
+          <p:cNvPr id="15" name="TextBox 14"/>
+          <p:cNvSpPr txBox="1"/>
+          <p:nvPr/>
+        </p:nvSpPr>
+        <p:spPr>
+          <a:xfrm>
+            <a:off x="4480560" y="1801368"/>
+            <a:ext cx="3017520" cy="347472"/>
+          </a:xfrm>
+          <a:prstGeom prst="rect">
+            <a:avLst/>
+          </a:prstGeom>
+          <a:noFill/>
+        </p:spPr>
+        <p:txBody>
+          <a:bodyPr wrap="square" anchor="t">
+            <a:noAutofit/>
+          </a:bodyPr>
+          <a:lstStyle/>
+          <a:p>
+            <a:pPr algn="ctr"/>
+            <a:r>
+              <a:rPr sz="1100" b="0">
+                <a:solidFill>
+                  <a:srgbClr val="1F2937"/>
+                </a:solidFill>
+                <a:latin typeface="Microsoft YaHei"/>
+              </a:rPr>
+              <a:t>以市场为导向的技术创新</a:t>
+            </a:r>
+          </a:p>
+        </p:txBody>
+      </p:sp>
+      <p:cxnSp>
+        <p:nvCxnSpPr>
+          <p:cNvPr id="16" name="Connector 15"/>
+          <p:cNvCxnSpPr/>
+          <p:nvPr/>
+        </p:nvCxnSpPr>
+        <p:spPr>
+          <a:xfrm>
+            <a:off x="1463040" y="1828800"/>
+            <a:ext cx="0" cy="694944"/>
+          </a:xfrm>
+          <a:prstGeom prst="line">
+            <a:avLst/>
+          </a:prstGeom>
+          <a:ln w="12700">
+            <a:solidFill>
+              <a:srgbClr val="6B7280"/>
+            </a:solidFill>
+            <a:prstDash val="sysDash"/>
+          </a:ln>
+        </p:spPr>
+        <p:style>
+          <a:lnRef idx="2">
+            <a:schemeClr val="accent1"/>
+          </a:lnRef>
+          <a:fillRef idx="0">
+            <a:schemeClr val="accent1"/>
+          </a:fillRef>
+          <a:effectRef idx="1">
+            <a:schemeClr val="accent1"/>
+          </a:effectRef>
+          <a:fontRef idx="minor">
+            <a:schemeClr val="tx1"/>
+          </a:fontRef>
+        </p:style>
+      </p:cxnSp>
+      <p:cxnSp>
+        <p:nvCxnSpPr>
+          <p:cNvPr id="17" name="Connector 16"/>
+          <p:cNvCxnSpPr/>
+          <p:nvPr/>
+        </p:nvCxnSpPr>
+        <p:spPr>
+          <a:xfrm>
+            <a:off x="4297680" y="1828800"/>
+            <a:ext cx="0" cy="694944"/>
+          </a:xfrm>
+          <a:prstGeom prst="line">
+            <a:avLst/>
+          </a:prstGeom>
+          <a:ln w="12700">
+            <a:solidFill>
+              <a:srgbClr val="6B7280"/>
+            </a:solidFill>
+            <a:prstDash val="sysDash"/>
+          </a:ln>
+        </p:spPr>
+        <p:style>
+          <a:lnRef idx="2">
+            <a:schemeClr val="accent1"/>
+          </a:lnRef>
+          <a:fillRef idx="0">
+            <a:schemeClr val="accent1"/>
+          </a:fillRef>
+          <a:effectRef idx="1">
+            <a:schemeClr val="accent1"/>
+          </a:effectRef>
+          <a:fontRef idx="minor">
+            <a:schemeClr val="tx1"/>
+          </a:fontRef>
+        </p:style>
+      </p:cxnSp>
+      <p:cxnSp>
+        <p:nvCxnSpPr>
+          <p:cNvPr id="18" name="Connector 17"/>
+          <p:cNvCxnSpPr/>
+          <p:nvPr/>
+        </p:nvCxnSpPr>
+        <p:spPr>
+          <a:xfrm>
+            <a:off x="7680960" y="1828800"/>
+            <a:ext cx="0" cy="694944"/>
+          </a:xfrm>
+          <a:prstGeom prst="line">
+            <a:avLst/>
+          </a:prstGeom>
+          <a:ln w="12700">
+            <a:solidFill>
+              <a:srgbClr val="6B7280"/>
+            </a:solidFill>
+            <a:prstDash val="sysDash"/>
+          </a:ln>
+        </p:spPr>
+        <p:style>
+          <a:lnRef idx="2">
+            <a:schemeClr val="accent1"/>
+          </a:lnRef>
+          <a:fillRef idx="0">
+            <a:schemeClr val="accent1"/>
+          </a:fillRef>
+          <a:effectRef idx="1">
+            <a:schemeClr val="accent1"/>
+          </a:effectRef>
+          <a:fontRef idx="minor">
+            <a:schemeClr val="tx1"/>
+          </a:fontRef>
+        </p:style>
+      </p:cxnSp>
+      <p:cxnSp>
+        <p:nvCxnSpPr>
+          <p:cNvPr id="19" name="Connector 18"/>
+          <p:cNvCxnSpPr/>
+          <p:nvPr/>
+        </p:nvCxnSpPr>
+        <p:spPr>
+          <a:xfrm>
+            <a:off x="10561320" y="1828800"/>
+            <a:ext cx="0" cy="694944"/>
+          </a:xfrm>
+          <a:prstGeom prst="line">
+            <a:avLst/>
+          </a:prstGeom>
+          <a:ln w="12700">
+            <a:solidFill>
+              <a:srgbClr val="6B7280"/>
+            </a:solidFill>
+            <a:prstDash val="sysDash"/>
+          </a:ln>
+        </p:spPr>
+        <p:style>
+          <a:lnRef idx="2">
+            <a:schemeClr val="accent1"/>
+          </a:lnRef>
+          <a:fillRef idx="0">
+            <a:schemeClr val="accent1"/>
+          </a:fillRef>
+          <a:effectRef idx="1">
+            <a:schemeClr val="accent1"/>
+          </a:effectRef>
+          <a:fontRef idx="minor">
+            <a:schemeClr val="tx1"/>
+          </a:fontRef>
+        </p:style>
+      </p:cxnSp>
+      <p:sp>
+        <p:nvSpPr>
+          <p:cNvPr id="20" name="Rounded Rectangle 19"/>
+          <p:cNvSpPr/>
+          <p:nvPr/>
+        </p:nvSpPr>
+        <p:spPr>
+          <a:xfrm>
+            <a:off x="603504" y="2578608"/>
+            <a:ext cx="1719072" cy="658368"/>
           </a:xfrm>
           <a:prstGeom prst="roundRect">
             <a:avLst/>
@@ -4915,14 +5588,14 @@
       </p:sp>
       <p:sp>
         <p:nvSpPr>
-          <p:cNvPr id="5" name="TextBox 4"/>
+          <p:cNvPr id="21" name="TextBox 20"/>
           <p:cNvSpPr txBox="1"/>
           <p:nvPr/>
         </p:nvSpPr>
         <p:spPr>
           <a:xfrm>
-            <a:off x="1234440" y="1481328"/>
-            <a:ext cx="9692640" cy="365760"/>
+            <a:off x="694944" y="2624328"/>
+            <a:ext cx="1536192" cy="228600"/>
           </a:xfrm>
           <a:prstGeom prst="rect">
             <a:avLst/>
@@ -4935,81 +5608,29 @@
           </a:bodyPr>
           <a:lstStyle/>
           <a:p>
-            <a:pPr algn="ctr"/>
-            <a:r>
-              <a:rPr sz="2200" b="1">
+            <a:pPr algn="l"/>
+            <a:r>
+              <a:rPr sz="1200" b="1">
                 <a:solidFill>
                   <a:srgbClr val="132B4D"/>
                 </a:solidFill>
                 <a:latin typeface="Microsoft YaHei"/>
               </a:rPr>
-              <a:t>本研究将围绕"应用驱动、体验为先、软硬协同、双轮转化"展开系统研究。</a:t>
-            </a:r>
-          </a:p>
-        </p:txBody>
-      </p:sp>
-      <p:sp>
-        <p:nvSpPr>
-          <p:cNvPr id="6" name="Oval 5"/>
-          <p:cNvSpPr/>
-          <p:nvPr/>
-        </p:nvSpPr>
-        <p:spPr>
-          <a:xfrm>
-            <a:off x="1828800" y="2651760"/>
-            <a:ext cx="457200" cy="457200"/>
-          </a:xfrm>
-          <a:prstGeom prst="ellipse">
-            <a:avLst/>
-          </a:prstGeom>
-          <a:solidFill>
-            <a:srgbClr val="132B4D"/>
-          </a:solidFill>
-          <a:ln>
-            <a:noFill/>
-          </a:ln>
-        </p:spPr>
-        <p:style>
-          <a:lnRef idx="1">
-            <a:schemeClr val="accent1"/>
-          </a:lnRef>
-          <a:fillRef idx="3">
-            <a:schemeClr val="accent1"/>
-          </a:fillRef>
-          <a:effectRef idx="2">
-            <a:schemeClr val="accent1"/>
-          </a:effectRef>
-          <a:fontRef idx="minor">
-            <a:schemeClr val="lt1"/>
-          </a:fontRef>
-        </p:style>
-        <p:txBody>
-          <a:bodyPr rtlCol="0" anchor="ctr"/>
-          <a:lstStyle/>
-          <a:p>
-            <a:pPr algn="ctr"/>
-            <a:r>
-              <a:rPr sz="2000" b="1">
-                <a:solidFill>
-                  <a:srgbClr val="FFFFFF"/>
-                </a:solidFill>
-                <a:latin typeface="Microsoft YaHei"/>
-              </a:rPr>
-              <a:t>1</a:t>
-            </a:r>
-          </a:p>
-        </p:txBody>
-      </p:sp>
-      <p:sp>
-        <p:nvSpPr>
-          <p:cNvPr id="7" name="TextBox 6"/>
+              <a:t>硬件</a:t>
+            </a:r>
+          </a:p>
+        </p:txBody>
+      </p:sp>
+      <p:sp>
+        <p:nvSpPr>
+          <p:cNvPr id="22" name="TextBox 21"/>
           <p:cNvSpPr txBox="1"/>
           <p:nvPr/>
         </p:nvSpPr>
         <p:spPr>
           <a:xfrm>
-            <a:off x="2468880" y="2724912"/>
-            <a:ext cx="7315200" cy="274320"/>
+            <a:off x="694944" y="2871216"/>
+            <a:ext cx="1536192" cy="219456"/>
           </a:xfrm>
           <a:prstGeom prst="rect">
             <a:avLst/>
@@ -5024,36 +5645,38 @@
           <a:p>
             <a:pPr algn="l"/>
             <a:r>
-              <a:rPr sz="1600" b="0">
-                <a:solidFill>
-                  <a:srgbClr val="1F2937"/>
-                </a:solidFill>
-                <a:latin typeface="Microsoft YaHei"/>
-              </a:rPr>
-              <a:t>点题：回答T公司如何把AI应用软件真正转化为商业价值。</a:t>
-            </a:r>
-          </a:p>
-        </p:txBody>
-      </p:sp>
-      <p:sp>
-        <p:nvSpPr>
-          <p:cNvPr id="8" name="Oval 7"/>
+              <a:rPr sz="1000" b="0">
+                <a:solidFill>
+                  <a:srgbClr val="6B7280"/>
+                </a:solidFill>
+                <a:latin typeface="Microsoft YaHei"/>
+              </a:rPr>
+              <a:t>纯硬件，无应用生态</a:t>
+            </a:r>
+          </a:p>
+        </p:txBody>
+      </p:sp>
+      <p:sp>
+        <p:nvSpPr>
+          <p:cNvPr id="23" name="Rounded Rectangle 22"/>
           <p:cNvSpPr/>
           <p:nvPr/>
         </p:nvSpPr>
         <p:spPr>
           <a:xfrm>
-            <a:off x="1828800" y="3456432"/>
-            <a:ext cx="457200" cy="457200"/>
-          </a:xfrm>
-          <a:prstGeom prst="ellipse">
-            <a:avLst/>
-          </a:prstGeom>
-          <a:solidFill>
-            <a:srgbClr val="2B6CB0"/>
+            <a:off x="3291840" y="2578608"/>
+            <a:ext cx="2011680" cy="658368"/>
+          </a:xfrm>
+          <a:prstGeom prst="roundRect">
+            <a:avLst/>
+          </a:prstGeom>
+          <a:solidFill>
+            <a:srgbClr val="FFFFFF"/>
           </a:solidFill>
           <a:ln>
-            <a:noFill/>
+            <a:solidFill>
+              <a:srgbClr val="D2DBE6"/>
+            </a:solidFill>
           </a:ln>
         </p:spPr>
         <p:style>
@@ -5075,28 +5698,19 @@
           <a:lstStyle/>
           <a:p>
             <a:pPr algn="ctr"/>
-            <a:r>
-              <a:rPr sz="2000" b="1">
-                <a:solidFill>
-                  <a:srgbClr val="FFFFFF"/>
-                </a:solidFill>
-                <a:latin typeface="Microsoft YaHei"/>
-              </a:rPr>
-              <a:t>2</a:t>
-            </a:r>
-          </a:p>
-        </p:txBody>
-      </p:sp>
-      <p:sp>
-        <p:nvSpPr>
-          <p:cNvPr id="9" name="TextBox 8"/>
+          </a:p>
+        </p:txBody>
+      </p:sp>
+      <p:sp>
+        <p:nvSpPr>
+          <p:cNvPr id="24" name="TextBox 23"/>
           <p:cNvSpPr txBox="1"/>
           <p:nvPr/>
         </p:nvSpPr>
         <p:spPr>
           <a:xfrm>
-            <a:off x="2468880" y="3529584"/>
-            <a:ext cx="7315200" cy="274320"/>
+            <a:off x="3383280" y="2624328"/>
+            <a:ext cx="1828800" cy="228600"/>
           </a:xfrm>
           <a:prstGeom prst="rect">
             <a:avLst/>
@@ -5111,79 +5725,27 @@
           <a:p>
             <a:pPr algn="l"/>
             <a:r>
-              <a:rPr sz="1600" b="0">
-                <a:solidFill>
-                  <a:srgbClr val="1F2937"/>
-                </a:solidFill>
-                <a:latin typeface="Microsoft YaHei"/>
-              </a:rPr>
-              <a:t>聚焦：围绕"有算力、无应用"的典型问题展开诊断。</a:t>
-            </a:r>
-          </a:p>
-        </p:txBody>
-      </p:sp>
-      <p:sp>
-        <p:nvSpPr>
-          <p:cNvPr id="10" name="Oval 9"/>
-          <p:cNvSpPr/>
-          <p:nvPr/>
-        </p:nvSpPr>
-        <p:spPr>
-          <a:xfrm>
-            <a:off x="1828800" y="4261104"/>
-            <a:ext cx="457200" cy="457200"/>
-          </a:xfrm>
-          <a:prstGeom prst="ellipse">
-            <a:avLst/>
-          </a:prstGeom>
-          <a:solidFill>
-            <a:srgbClr val="1F7A8C"/>
-          </a:solidFill>
-          <a:ln>
-            <a:noFill/>
-          </a:ln>
-        </p:spPr>
-        <p:style>
-          <a:lnRef idx="1">
-            <a:schemeClr val="accent1"/>
-          </a:lnRef>
-          <a:fillRef idx="3">
-            <a:schemeClr val="accent1"/>
-          </a:fillRef>
-          <a:effectRef idx="2">
-            <a:schemeClr val="accent1"/>
-          </a:effectRef>
-          <a:fontRef idx="minor">
-            <a:schemeClr val="lt1"/>
-          </a:fontRef>
-        </p:style>
-        <p:txBody>
-          <a:bodyPr rtlCol="0" anchor="ctr"/>
-          <a:lstStyle/>
-          <a:p>
-            <a:pPr algn="ctr"/>
-            <a:r>
-              <a:rPr sz="2000" b="1">
-                <a:solidFill>
-                  <a:srgbClr val="FFFFFF"/>
-                </a:solidFill>
-                <a:latin typeface="Microsoft YaHei"/>
-              </a:rPr>
-              <a:t>3</a:t>
-            </a:r>
-          </a:p>
-        </p:txBody>
-      </p:sp>
-      <p:sp>
-        <p:nvSpPr>
-          <p:cNvPr id="11" name="TextBox 10"/>
+              <a:rPr sz="1200" b="1">
+                <a:solidFill>
+                  <a:srgbClr val="132B4D"/>
+                </a:solidFill>
+                <a:latin typeface="Microsoft YaHei"/>
+              </a:rPr>
+              <a:t>T公司当前处境</a:t>
+            </a:r>
+          </a:p>
+        </p:txBody>
+      </p:sp>
+      <p:sp>
+        <p:nvSpPr>
+          <p:cNvPr id="25" name="TextBox 24"/>
           <p:cNvSpPr txBox="1"/>
           <p:nvPr/>
         </p:nvSpPr>
         <p:spPr>
           <a:xfrm>
-            <a:off x="2468880" y="4334256"/>
-            <a:ext cx="7315200" cy="274320"/>
+            <a:off x="3383280" y="2871216"/>
+            <a:ext cx="1828800" cy="219456"/>
           </a:xfrm>
           <a:prstGeom prst="rect">
             <a:avLst/>
@@ -5198,36 +5760,38 @@
           <a:p>
             <a:pPr algn="l"/>
             <a:r>
-              <a:rPr sz="1600" b="0">
-                <a:solidFill>
-                  <a:srgbClr val="1F2937"/>
-                </a:solidFill>
-                <a:latin typeface="Microsoft YaHei"/>
-              </a:rPr>
-              <a:t>方案：构建"软件直接变现 + OEM集成拉动"双轮驱动体系。</a:t>
-            </a:r>
-          </a:p>
-        </p:txBody>
-      </p:sp>
-      <p:sp>
-        <p:nvSpPr>
-          <p:cNvPr id="12" name="Oval 11"/>
+              <a:rPr sz="1000" b="0">
+                <a:solidFill>
+                  <a:srgbClr val="6B7280"/>
+                </a:solidFill>
+                <a:latin typeface="Microsoft YaHei"/>
+              </a:rPr>
+              <a:t>有算力，软件转化低效</a:t>
+            </a:r>
+          </a:p>
+        </p:txBody>
+      </p:sp>
+      <p:sp>
+        <p:nvSpPr>
+          <p:cNvPr id="26" name="Rounded Rectangle 25"/>
           <p:cNvSpPr/>
           <p:nvPr/>
         </p:nvSpPr>
         <p:spPr>
           <a:xfrm>
-            <a:off x="1828800" y="5065776"/>
-            <a:ext cx="457200" cy="457200"/>
-          </a:xfrm>
-          <a:prstGeom prst="ellipse">
-            <a:avLst/>
-          </a:prstGeom>
-          <a:solidFill>
-            <a:srgbClr val="ED8936"/>
+            <a:off x="6675120" y="2578608"/>
+            <a:ext cx="2011680" cy="658368"/>
+          </a:xfrm>
+          <a:prstGeom prst="roundRect">
+            <a:avLst/>
+          </a:prstGeom>
+          <a:solidFill>
+            <a:srgbClr val="FFFFFF"/>
           </a:solidFill>
           <a:ln>
-            <a:noFill/>
+            <a:solidFill>
+              <a:srgbClr val="D2DBE6"/>
+            </a:solidFill>
           </a:ln>
         </p:spPr>
         <p:style>
@@ -5249,28 +5813,19 @@
           <a:lstStyle/>
           <a:p>
             <a:pPr algn="ctr"/>
-            <a:r>
-              <a:rPr sz="2000" b="1">
-                <a:solidFill>
-                  <a:srgbClr val="FFFFFF"/>
-                </a:solidFill>
-                <a:latin typeface="Microsoft YaHei"/>
-              </a:rPr>
-              <a:t>4</a:t>
-            </a:r>
-          </a:p>
-        </p:txBody>
-      </p:sp>
-      <p:sp>
-        <p:nvSpPr>
-          <p:cNvPr id="13" name="TextBox 12"/>
+          </a:p>
+        </p:txBody>
+      </p:sp>
+      <p:sp>
+        <p:nvSpPr>
+          <p:cNvPr id="27" name="TextBox 26"/>
           <p:cNvSpPr txBox="1"/>
           <p:nvPr/>
         </p:nvSpPr>
         <p:spPr>
           <a:xfrm>
-            <a:off x="2468880" y="5138928"/>
-            <a:ext cx="7315200" cy="274320"/>
+            <a:off x="6766560" y="2624328"/>
+            <a:ext cx="1828800" cy="228600"/>
           </a:xfrm>
           <a:prstGeom prst="rect">
             <a:avLst/>
@@ -5285,33 +5840,228 @@
           <a:p>
             <a:pPr algn="l"/>
             <a:r>
-              <a:rPr sz="1600" b="0">
-                <a:solidFill>
-                  <a:srgbClr val="1F2937"/>
-                </a:solidFill>
-                <a:latin typeface="Microsoft YaHei"/>
-              </a:rPr>
-              <a:t>目标：为T公司及同类中型AI企业提供可复制的转化路径。</a:t>
-            </a:r>
-          </a:p>
-        </p:txBody>
-      </p:sp>
-      <p:sp>
-        <p:nvSpPr>
-          <p:cNvPr id="14" name="Rounded Rectangle 13"/>
+              <a:rPr sz="1200" b="1">
+                <a:solidFill>
+                  <a:srgbClr val="132B4D"/>
+                </a:solidFill>
+                <a:latin typeface="Microsoft YaHei"/>
+              </a:rPr>
+              <a:t>软硬协同目标</a:t>
+            </a:r>
+          </a:p>
+        </p:txBody>
+      </p:sp>
+      <p:sp>
+        <p:nvSpPr>
+          <p:cNvPr id="28" name="TextBox 27"/>
+          <p:cNvSpPr txBox="1"/>
+          <p:nvPr/>
+        </p:nvSpPr>
+        <p:spPr>
+          <a:xfrm>
+            <a:off x="6766560" y="2871216"/>
+            <a:ext cx="1828800" cy="219456"/>
+          </a:xfrm>
+          <a:prstGeom prst="rect">
+            <a:avLst/>
+          </a:prstGeom>
+          <a:noFill/>
+        </p:spPr>
+        <p:txBody>
+          <a:bodyPr wrap="square" anchor="t">
+            <a:noAutofit/>
+          </a:bodyPr>
+          <a:lstStyle/>
+          <a:p>
+            <a:pPr algn="l"/>
+            <a:r>
+              <a:rPr sz="1000" b="0">
+                <a:solidFill>
+                  <a:srgbClr val="6B7280"/>
+                </a:solidFill>
+                <a:latin typeface="Microsoft YaHei"/>
+              </a:rPr>
+              <a:t>应用体验驱动硬件增长</a:t>
+            </a:r>
+          </a:p>
+        </p:txBody>
+      </p:sp>
+      <p:sp>
+        <p:nvSpPr>
+          <p:cNvPr id="29" name="Rounded Rectangle 28"/>
           <p:cNvSpPr/>
           <p:nvPr/>
         </p:nvSpPr>
         <p:spPr>
           <a:xfrm>
-            <a:off x="4434840" y="5897880"/>
-            <a:ext cx="3337560" cy="438912"/>
+            <a:off x="9701784" y="2578608"/>
+            <a:ext cx="1719072" cy="658368"/>
           </a:xfrm>
           <a:prstGeom prst="roundRect">
             <a:avLst/>
           </a:prstGeom>
           <a:solidFill>
-            <a:srgbClr val="132B4D"/>
+            <a:srgbClr val="FFFFFF"/>
+          </a:solidFill>
+          <a:ln>
+            <a:solidFill>
+              <a:srgbClr val="D2DBE6"/>
+            </a:solidFill>
+          </a:ln>
+        </p:spPr>
+        <p:style>
+          <a:lnRef idx="1">
+            <a:schemeClr val="accent1"/>
+          </a:lnRef>
+          <a:fillRef idx="3">
+            <a:schemeClr val="accent1"/>
+          </a:fillRef>
+          <a:effectRef idx="2">
+            <a:schemeClr val="accent1"/>
+          </a:effectRef>
+          <a:fontRef idx="minor">
+            <a:schemeClr val="lt1"/>
+          </a:fontRef>
+        </p:style>
+        <p:txBody>
+          <a:bodyPr rtlCol="0" anchor="ctr"/>
+          <a:lstStyle/>
+          <a:p>
+            <a:pPr algn="ctr"/>
+          </a:p>
+        </p:txBody>
+      </p:sp>
+      <p:sp>
+        <p:nvSpPr>
+          <p:cNvPr id="30" name="TextBox 29"/>
+          <p:cNvSpPr txBox="1"/>
+          <p:nvPr/>
+        </p:nvSpPr>
+        <p:spPr>
+          <a:xfrm>
+            <a:off x="9793224" y="2624328"/>
+            <a:ext cx="1536192" cy="228600"/>
+          </a:xfrm>
+          <a:prstGeom prst="rect">
+            <a:avLst/>
+          </a:prstGeom>
+          <a:noFill/>
+        </p:spPr>
+        <p:txBody>
+          <a:bodyPr wrap="square" anchor="t">
+            <a:noAutofit/>
+          </a:bodyPr>
+          <a:lstStyle/>
+          <a:p>
+            <a:pPr algn="l"/>
+            <a:r>
+              <a:rPr sz="1200" b="1">
+                <a:solidFill>
+                  <a:srgbClr val="132B4D"/>
+                </a:solidFill>
+                <a:latin typeface="Microsoft YaHei"/>
+              </a:rPr>
+              <a:t>纯软件（远期）</a:t>
+            </a:r>
+          </a:p>
+        </p:txBody>
+      </p:sp>
+      <p:sp>
+        <p:nvSpPr>
+          <p:cNvPr id="31" name="TextBox 30"/>
+          <p:cNvSpPr txBox="1"/>
+          <p:nvPr/>
+        </p:nvSpPr>
+        <p:spPr>
+          <a:xfrm>
+            <a:off x="9793224" y="2871216"/>
+            <a:ext cx="1536192" cy="219456"/>
+          </a:xfrm>
+          <a:prstGeom prst="rect">
+            <a:avLst/>
+          </a:prstGeom>
+          <a:noFill/>
+        </p:spPr>
+        <p:txBody>
+          <a:bodyPr wrap="square" anchor="t">
+            <a:noAutofit/>
+          </a:bodyPr>
+          <a:lstStyle/>
+          <a:p>
+            <a:pPr algn="l"/>
+            <a:r>
+              <a:rPr sz="1000" b="0">
+                <a:solidFill>
+                  <a:srgbClr val="6B7280"/>
+                </a:solidFill>
+                <a:latin typeface="Microsoft YaHei"/>
+              </a:rPr>
+              <a:t>第三方生态，脱离硬件</a:t>
+            </a:r>
+          </a:p>
+        </p:txBody>
+      </p:sp>
+      <p:sp>
+        <p:nvSpPr>
+          <p:cNvPr id="32" name="Rounded Rectangle 31"/>
+          <p:cNvSpPr/>
+          <p:nvPr/>
+        </p:nvSpPr>
+        <p:spPr>
+          <a:xfrm>
+            <a:off x="384048" y="3364992"/>
+            <a:ext cx="3547872" cy="2148840"/>
+          </a:xfrm>
+          <a:prstGeom prst="roundRect">
+            <a:avLst/>
+          </a:prstGeom>
+          <a:solidFill>
+            <a:srgbClr val="FFFFFF"/>
+          </a:solidFill>
+          <a:ln>
+            <a:solidFill>
+              <a:srgbClr val="D2DBE6"/>
+            </a:solidFill>
+          </a:ln>
+        </p:spPr>
+        <p:style>
+          <a:lnRef idx="1">
+            <a:schemeClr val="accent1"/>
+          </a:lnRef>
+          <a:fillRef idx="3">
+            <a:schemeClr val="accent1"/>
+          </a:fillRef>
+          <a:effectRef idx="2">
+            <a:schemeClr val="accent1"/>
+          </a:effectRef>
+          <a:fontRef idx="minor">
+            <a:schemeClr val="lt1"/>
+          </a:fontRef>
+        </p:style>
+        <p:txBody>
+          <a:bodyPr rtlCol="0" anchor="ctr"/>
+          <a:lstStyle/>
+          <a:p>
+            <a:pPr algn="ctr"/>
+          </a:p>
+        </p:txBody>
+      </p:sp>
+      <p:sp>
+        <p:nvSpPr>
+          <p:cNvPr id="33" name="Rectangle 32"/>
+          <p:cNvSpPr/>
+          <p:nvPr/>
+        </p:nvSpPr>
+        <p:spPr>
+          <a:xfrm>
+            <a:off x="384048" y="3364992"/>
+            <a:ext cx="3547872" cy="457200"/>
+          </a:xfrm>
+          <a:prstGeom prst="rect">
+            <a:avLst/>
+          </a:prstGeom>
+          <a:solidFill>
+            <a:srgbClr val="2B6CB0"/>
           </a:solidFill>
           <a:ln>
             <a:noFill/>
@@ -5336,21 +6086,539 @@
           <a:lstStyle/>
           <a:p>
             <a:pPr algn="ctr"/>
-            <a:r>
-              <a:rPr sz="1600" b="1">
+          </a:p>
+        </p:txBody>
+      </p:sp>
+      <p:sp>
+        <p:nvSpPr>
+          <p:cNvPr id="34" name="TextBox 33"/>
+          <p:cNvSpPr txBox="1"/>
+          <p:nvPr/>
+        </p:nvSpPr>
+        <p:spPr>
+          <a:xfrm>
+            <a:off x="521207" y="3438144"/>
+            <a:ext cx="3273552" cy="274320"/>
+          </a:xfrm>
+          <a:prstGeom prst="rect">
+            <a:avLst/>
+          </a:prstGeom>
+          <a:noFill/>
+        </p:spPr>
+        <p:txBody>
+          <a:bodyPr wrap="square" anchor="t">
+            <a:noAutofit/>
+          </a:bodyPr>
+          <a:lstStyle/>
+          <a:p>
+            <a:pPr algn="l"/>
+            <a:r>
+              <a:rPr sz="1500" b="1">
                 <a:solidFill>
                   <a:srgbClr val="FFFFFF"/>
                 </a:solidFill>
                 <a:latin typeface="Microsoft YaHei"/>
               </a:rPr>
-              <a:t>感谢聆听  ·  请各位老师批评指正</a:t>
-            </a:r>
-          </a:p>
-        </p:txBody>
-      </p:sp>
-      <p:sp>
-        <p:nvSpPr>
-          <p:cNvPr id="15" name="TextBox 14"/>
+              <a:t>正（Thesis）：算力基础</a:t>
+            </a:r>
+          </a:p>
+        </p:txBody>
+      </p:sp>
+      <p:sp>
+        <p:nvSpPr>
+          <p:cNvPr id="35" name="TextBox 34"/>
+          <p:cNvSpPr txBox="1"/>
+          <p:nvPr/>
+        </p:nvSpPr>
+        <p:spPr>
+          <a:xfrm>
+            <a:off x="585216" y="3931920"/>
+            <a:ext cx="3145536" cy="1435608"/>
+          </a:xfrm>
+          <a:prstGeom prst="rect">
+            <a:avLst/>
+          </a:prstGeom>
+          <a:noFill/>
+        </p:spPr>
+        <p:txBody>
+          <a:bodyPr wrap="square">
+            <a:spAutoFit/>
+          </a:bodyPr>
+          <a:lstStyle/>
+          <a:p>
+            <a:r>
+              <a:rPr sz="1250" b="0">
+                <a:solidFill>
+                  <a:srgbClr val="1F2937"/>
+                </a:solidFill>
+                <a:latin typeface="Microsoft YaHei"/>
+              </a:rPr>
+              <a:t>• T公司具备自研芯片算力优势，底层工具链相对成熟。</a:t>
+            </a:r>
+          </a:p>
+          <a:p>
+            <a:r>
+              <a:rPr sz="1250" b="0">
+                <a:solidFill>
+                  <a:srgbClr val="1F2937"/>
+                </a:solidFill>
+                <a:latin typeface="Microsoft YaHei"/>
+              </a:rPr>
+              <a:t>• 硬件性能已达行业领先，为技术转化奠定基础。</a:t>
+            </a:r>
+          </a:p>
+          <a:p>
+            <a:r>
+              <a:rPr sz="1250" b="1">
+                <a:solidFill>
+                  <a:srgbClr val="2B6CB0"/>
+                </a:solidFill>
+                <a:latin typeface="Microsoft YaHei"/>
+              </a:rPr>
+              <a:t>→ 但技术价值尚未有效传递给用户</a:t>
+            </a:r>
+          </a:p>
+        </p:txBody>
+      </p:sp>
+      <p:sp>
+        <p:nvSpPr>
+          <p:cNvPr id="36" name="Rounded Rectangle 35"/>
+          <p:cNvSpPr/>
+          <p:nvPr/>
+        </p:nvSpPr>
+        <p:spPr>
+          <a:xfrm>
+            <a:off x="4315968" y="3364992"/>
+            <a:ext cx="3547872" cy="2148840"/>
+          </a:xfrm>
+          <a:prstGeom prst="roundRect">
+            <a:avLst/>
+          </a:prstGeom>
+          <a:solidFill>
+            <a:srgbClr val="FFFFFF"/>
+          </a:solidFill>
+          <a:ln>
+            <a:solidFill>
+              <a:srgbClr val="D2DBE6"/>
+            </a:solidFill>
+          </a:ln>
+        </p:spPr>
+        <p:style>
+          <a:lnRef idx="1">
+            <a:schemeClr val="accent1"/>
+          </a:lnRef>
+          <a:fillRef idx="3">
+            <a:schemeClr val="accent1"/>
+          </a:fillRef>
+          <a:effectRef idx="2">
+            <a:schemeClr val="accent1"/>
+          </a:effectRef>
+          <a:fontRef idx="minor">
+            <a:schemeClr val="lt1"/>
+          </a:fontRef>
+        </p:style>
+        <p:txBody>
+          <a:bodyPr rtlCol="0" anchor="ctr"/>
+          <a:lstStyle/>
+          <a:p>
+            <a:pPr algn="ctr"/>
+          </a:p>
+        </p:txBody>
+      </p:sp>
+      <p:sp>
+        <p:nvSpPr>
+          <p:cNvPr id="37" name="Rectangle 36"/>
+          <p:cNvSpPr/>
+          <p:nvPr/>
+        </p:nvSpPr>
+        <p:spPr>
+          <a:xfrm>
+            <a:off x="4315968" y="3364992"/>
+            <a:ext cx="3547872" cy="457200"/>
+          </a:xfrm>
+          <a:prstGeom prst="rect">
+            <a:avLst/>
+          </a:prstGeom>
+          <a:solidFill>
+            <a:srgbClr val="E53E3E"/>
+          </a:solidFill>
+          <a:ln>
+            <a:noFill/>
+          </a:ln>
+        </p:spPr>
+        <p:style>
+          <a:lnRef idx="1">
+            <a:schemeClr val="accent1"/>
+          </a:lnRef>
+          <a:fillRef idx="3">
+            <a:schemeClr val="accent1"/>
+          </a:fillRef>
+          <a:effectRef idx="2">
+            <a:schemeClr val="accent1"/>
+          </a:effectRef>
+          <a:fontRef idx="minor">
+            <a:schemeClr val="lt1"/>
+          </a:fontRef>
+        </p:style>
+        <p:txBody>
+          <a:bodyPr rtlCol="0" anchor="ctr"/>
+          <a:lstStyle/>
+          <a:p>
+            <a:pPr algn="ctr"/>
+          </a:p>
+        </p:txBody>
+      </p:sp>
+      <p:sp>
+        <p:nvSpPr>
+          <p:cNvPr id="38" name="TextBox 37"/>
+          <p:cNvSpPr txBox="1"/>
+          <p:nvPr/>
+        </p:nvSpPr>
+        <p:spPr>
+          <a:xfrm>
+            <a:off x="4453128" y="3438144"/>
+            <a:ext cx="3273552" cy="274320"/>
+          </a:xfrm>
+          <a:prstGeom prst="rect">
+            <a:avLst/>
+          </a:prstGeom>
+          <a:noFill/>
+        </p:spPr>
+        <p:txBody>
+          <a:bodyPr wrap="square" anchor="t">
+            <a:noAutofit/>
+          </a:bodyPr>
+          <a:lstStyle/>
+          <a:p>
+            <a:pPr algn="l"/>
+            <a:r>
+              <a:rPr sz="1500" b="1">
+                <a:solidFill>
+                  <a:srgbClr val="FFFFFF"/>
+                </a:solidFill>
+                <a:latin typeface="Microsoft YaHei"/>
+              </a:rPr>
+              <a:t>反（Antithesis）：转化瓶颈</a:t>
+            </a:r>
+          </a:p>
+        </p:txBody>
+      </p:sp>
+      <p:sp>
+        <p:nvSpPr>
+          <p:cNvPr id="39" name="TextBox 38"/>
+          <p:cNvSpPr txBox="1"/>
+          <p:nvPr/>
+        </p:nvSpPr>
+        <p:spPr>
+          <a:xfrm>
+            <a:off x="4517136" y="3931920"/>
+            <a:ext cx="3145536" cy="1435608"/>
+          </a:xfrm>
+          <a:prstGeom prst="rect">
+            <a:avLst/>
+          </a:prstGeom>
+          <a:noFill/>
+        </p:spPr>
+        <p:txBody>
+          <a:bodyPr wrap="square">
+            <a:spAutoFit/>
+          </a:bodyPr>
+          <a:lstStyle/>
+          <a:p>
+            <a:r>
+              <a:rPr sz="1250" b="0">
+                <a:solidFill>
+                  <a:srgbClr val="1F2937"/>
+                </a:solidFill>
+                <a:latin typeface="Microsoft YaHei"/>
+              </a:rPr>
+              <a:t>• 应用缺位、模式单一、组织协同不畅。</a:t>
+            </a:r>
+          </a:p>
+          <a:p>
+            <a:r>
+              <a:rPr sz="1250" b="0">
+                <a:solidFill>
+                  <a:srgbClr val="1F2937"/>
+                </a:solidFill>
+                <a:latin typeface="Microsoft YaHei"/>
+              </a:rPr>
+              <a:t>• "有算力、无应用"困境制约商业化落地。</a:t>
+            </a:r>
+          </a:p>
+          <a:p>
+            <a:r>
+              <a:rPr sz="1250" b="1">
+                <a:solidFill>
+                  <a:srgbClr val="E53E3E"/>
+                </a:solidFill>
+                <a:latin typeface="Microsoft YaHei"/>
+              </a:rPr>
+              <a:t>→ 陷入 f2 困境，转化效率偏低</a:t>
+            </a:r>
+          </a:p>
+        </p:txBody>
+      </p:sp>
+      <p:sp>
+        <p:nvSpPr>
+          <p:cNvPr id="40" name="Rounded Rectangle 39"/>
+          <p:cNvSpPr/>
+          <p:nvPr/>
+        </p:nvSpPr>
+        <p:spPr>
+          <a:xfrm>
+            <a:off x="8247888" y="3364992"/>
+            <a:ext cx="3547872" cy="2148840"/>
+          </a:xfrm>
+          <a:prstGeom prst="roundRect">
+            <a:avLst/>
+          </a:prstGeom>
+          <a:solidFill>
+            <a:srgbClr val="FFFFFF"/>
+          </a:solidFill>
+          <a:ln>
+            <a:solidFill>
+              <a:srgbClr val="D2DBE6"/>
+            </a:solidFill>
+          </a:ln>
+        </p:spPr>
+        <p:style>
+          <a:lnRef idx="1">
+            <a:schemeClr val="accent1"/>
+          </a:lnRef>
+          <a:fillRef idx="3">
+            <a:schemeClr val="accent1"/>
+          </a:fillRef>
+          <a:effectRef idx="2">
+            <a:schemeClr val="accent1"/>
+          </a:effectRef>
+          <a:fontRef idx="minor">
+            <a:schemeClr val="lt1"/>
+          </a:fontRef>
+        </p:style>
+        <p:txBody>
+          <a:bodyPr rtlCol="0" anchor="ctr"/>
+          <a:lstStyle/>
+          <a:p>
+            <a:pPr algn="ctr"/>
+          </a:p>
+        </p:txBody>
+      </p:sp>
+      <p:sp>
+        <p:nvSpPr>
+          <p:cNvPr id="41" name="Rectangle 40"/>
+          <p:cNvSpPr/>
+          <p:nvPr/>
+        </p:nvSpPr>
+        <p:spPr>
+          <a:xfrm>
+            <a:off x="8247888" y="3364992"/>
+            <a:ext cx="3547872" cy="457200"/>
+          </a:xfrm>
+          <a:prstGeom prst="rect">
+            <a:avLst/>
+          </a:prstGeom>
+          <a:solidFill>
+            <a:srgbClr val="38A169"/>
+          </a:solidFill>
+          <a:ln>
+            <a:noFill/>
+          </a:ln>
+        </p:spPr>
+        <p:style>
+          <a:lnRef idx="1">
+            <a:schemeClr val="accent1"/>
+          </a:lnRef>
+          <a:fillRef idx="3">
+            <a:schemeClr val="accent1"/>
+          </a:fillRef>
+          <a:effectRef idx="2">
+            <a:schemeClr val="accent1"/>
+          </a:effectRef>
+          <a:fontRef idx="minor">
+            <a:schemeClr val="lt1"/>
+          </a:fontRef>
+        </p:style>
+        <p:txBody>
+          <a:bodyPr rtlCol="0" anchor="ctr"/>
+          <a:lstStyle/>
+          <a:p>
+            <a:pPr algn="ctr"/>
+          </a:p>
+        </p:txBody>
+      </p:sp>
+      <p:sp>
+        <p:nvSpPr>
+          <p:cNvPr id="42" name="TextBox 41"/>
+          <p:cNvSpPr txBox="1"/>
+          <p:nvPr/>
+        </p:nvSpPr>
+        <p:spPr>
+          <a:xfrm>
+            <a:off x="8385048" y="3438144"/>
+            <a:ext cx="3273552" cy="274320"/>
+          </a:xfrm>
+          <a:prstGeom prst="rect">
+            <a:avLst/>
+          </a:prstGeom>
+          <a:noFill/>
+        </p:spPr>
+        <p:txBody>
+          <a:bodyPr wrap="square" anchor="t">
+            <a:noAutofit/>
+          </a:bodyPr>
+          <a:lstStyle/>
+          <a:p>
+            <a:pPr algn="l"/>
+            <a:r>
+              <a:rPr sz="1500" b="1">
+                <a:solidFill>
+                  <a:srgbClr val="FFFFFF"/>
+                </a:solidFill>
+                <a:latin typeface="Microsoft YaHei"/>
+              </a:rPr>
+              <a:t>合（Synthesis）：双轮驱动策略</a:t>
+            </a:r>
+          </a:p>
+        </p:txBody>
+      </p:sp>
+      <p:sp>
+        <p:nvSpPr>
+          <p:cNvPr id="43" name="TextBox 42"/>
+          <p:cNvSpPr txBox="1"/>
+          <p:nvPr/>
+        </p:nvSpPr>
+        <p:spPr>
+          <a:xfrm>
+            <a:off x="8449056" y="3931920"/>
+            <a:ext cx="3145536" cy="1435608"/>
+          </a:xfrm>
+          <a:prstGeom prst="rect">
+            <a:avLst/>
+          </a:prstGeom>
+          <a:noFill/>
+        </p:spPr>
+        <p:txBody>
+          <a:bodyPr wrap="square">
+            <a:spAutoFit/>
+          </a:bodyPr>
+          <a:lstStyle/>
+          <a:p>
+            <a:r>
+              <a:rPr sz="1250" b="0">
+                <a:solidFill>
+                  <a:srgbClr val="1F2937"/>
+                </a:solidFill>
+                <a:latin typeface="Microsoft YaHei"/>
+              </a:rPr>
+              <a:t>• 软件直接变现（SaaS/API）+ OEM集成拉动。</a:t>
+            </a:r>
+          </a:p>
+          <a:p>
+            <a:r>
+              <a:rPr sz="1250" b="0">
+                <a:solidFill>
+                  <a:srgbClr val="1F2937"/>
+                </a:solidFill>
+                <a:latin typeface="Microsoft YaHei"/>
+              </a:rPr>
+              <a:t>• 从 f2 穿越绿色区间，构建软硬协同生态。</a:t>
+            </a:r>
+          </a:p>
+          <a:p>
+            <a:r>
+              <a:rPr sz="1250" b="1">
+                <a:solidFill>
+                  <a:srgbClr val="38A169"/>
+                </a:solidFill>
+                <a:latin typeface="Microsoft YaHei"/>
+              </a:rPr>
+              <a:t>→ 技术价值 ⇌ 商业价值 协同提升</a:t>
+            </a:r>
+          </a:p>
+        </p:txBody>
+      </p:sp>
+      <p:sp>
+        <p:nvSpPr>
+          <p:cNvPr id="44" name="Rounded Rectangle 43"/>
+          <p:cNvSpPr/>
+          <p:nvPr/>
+        </p:nvSpPr>
+        <p:spPr>
+          <a:xfrm>
+            <a:off x="411480" y="5669280"/>
+            <a:ext cx="11384280" cy="566928"/>
+          </a:xfrm>
+          <a:prstGeom prst="roundRect">
+            <a:avLst/>
+          </a:prstGeom>
+          <a:solidFill>
+            <a:srgbClr val="132B4D"/>
+          </a:solidFill>
+          <a:ln>
+            <a:noFill/>
+          </a:ln>
+        </p:spPr>
+        <p:style>
+          <a:lnRef idx="1">
+            <a:schemeClr val="accent1"/>
+          </a:lnRef>
+          <a:fillRef idx="3">
+            <a:schemeClr val="accent1"/>
+          </a:fillRef>
+          <a:effectRef idx="2">
+            <a:schemeClr val="accent1"/>
+          </a:effectRef>
+          <a:fontRef idx="minor">
+            <a:schemeClr val="lt1"/>
+          </a:fontRef>
+        </p:style>
+        <p:txBody>
+          <a:bodyPr rtlCol="0" anchor="ctr"/>
+          <a:lstStyle/>
+          <a:p>
+            <a:pPr algn="ctr"/>
+          </a:p>
+        </p:txBody>
+      </p:sp>
+      <p:sp>
+        <p:nvSpPr>
+          <p:cNvPr id="45" name="TextBox 44"/>
+          <p:cNvSpPr txBox="1"/>
+          <p:nvPr/>
+        </p:nvSpPr>
+        <p:spPr>
+          <a:xfrm>
+            <a:off x="594360" y="5760720"/>
+            <a:ext cx="10972800" cy="365760"/>
+          </a:xfrm>
+          <a:prstGeom prst="rect">
+            <a:avLst/>
+          </a:prstGeom>
+          <a:noFill/>
+        </p:spPr>
+        <p:txBody>
+          <a:bodyPr wrap="square" anchor="t">
+            <a:noAutofit/>
+          </a:bodyPr>
+          <a:lstStyle/>
+          <a:p>
+            <a:pPr algn="ctr"/>
+            <a:r>
+              <a:rPr sz="1400" b="1">
+                <a:solidFill>
+                  <a:srgbClr val="FFFFFF"/>
+                </a:solidFill>
+                <a:latin typeface="Microsoft YaHei"/>
+              </a:rPr>
+              <a:t>研究的本质：推动T公司从 f2 穿越绿色区间、迈向 f3，以AI应用软件转化打通从"算力优势"到"商业价值"的最后一公里。</a:t>
+            </a:r>
+          </a:p>
+        </p:txBody>
+      </p:sp>
+      <p:sp>
+        <p:nvSpPr>
+          <p:cNvPr id="46" name="TextBox 45"/>
           <p:cNvSpPr txBox="1"/>
           <p:nvPr/>
         </p:nvSpPr>
@@ -5379,6 +6647,645 @@
                 <a:latin typeface="Microsoft YaHei"/>
               </a:rPr>
               <a:t>11</a:t>
+            </a:r>
+          </a:p>
+        </p:txBody>
+      </p:sp>
+    </p:spTree>
+  </p:cSld>
+  <p:clrMapOvr>
+    <a:masterClrMapping/>
+  </p:clrMapOvr>
+</p:sld>
+</file>
+
+<file path=ppt/slides/slide12.xml><?xml version="1.0" encoding="utf-8"?>
+<p:sld xmlns:a="http://schemas.openxmlformats.org/drawingml/2006/main" xmlns:p="http://schemas.openxmlformats.org/presentationml/2006/main" xmlns:r="http://schemas.openxmlformats.org/officeDocument/2006/relationships">
+  <p:cSld>
+    <p:spTree>
+      <p:nvGrpSpPr>
+        <p:cNvPr id="1" name=""/>
+        <p:cNvGrpSpPr/>
+        <p:nvPr/>
+      </p:nvGrpSpPr>
+      <p:grpSpPr/>
+      <p:sp>
+        <p:nvSpPr>
+          <p:cNvPr id="2" name="Rectangle 1"/>
+          <p:cNvSpPr/>
+          <p:nvPr/>
+        </p:nvSpPr>
+        <p:spPr>
+          <a:xfrm>
+            <a:off x="0" y="0"/>
+            <a:ext cx="12191695" cy="6858000"/>
+          </a:xfrm>
+          <a:prstGeom prst="rect">
+            <a:avLst/>
+          </a:prstGeom>
+          <a:solidFill>
+            <a:srgbClr val="F2F7FD"/>
+          </a:solidFill>
+          <a:ln>
+            <a:noFill/>
+          </a:ln>
+        </p:spPr>
+        <p:style>
+          <a:lnRef idx="1">
+            <a:schemeClr val="accent1"/>
+          </a:lnRef>
+          <a:fillRef idx="3">
+            <a:schemeClr val="accent1"/>
+          </a:fillRef>
+          <a:effectRef idx="2">
+            <a:schemeClr val="accent1"/>
+          </a:effectRef>
+          <a:fontRef idx="minor">
+            <a:schemeClr val="lt1"/>
+          </a:fontRef>
+        </p:style>
+        <p:txBody>
+          <a:bodyPr rtlCol="0" anchor="ctr"/>
+          <a:lstStyle/>
+          <a:p>
+            <a:pPr algn="ctr"/>
+          </a:p>
+        </p:txBody>
+      </p:sp>
+      <p:sp>
+        <p:nvSpPr>
+          <p:cNvPr id="3" name="Rectangle 2"/>
+          <p:cNvSpPr/>
+          <p:nvPr/>
+        </p:nvSpPr>
+        <p:spPr>
+          <a:xfrm>
+            <a:off x="0" y="0"/>
+            <a:ext cx="12191695" cy="731520"/>
+          </a:xfrm>
+          <a:prstGeom prst="rect">
+            <a:avLst/>
+          </a:prstGeom>
+          <a:solidFill>
+            <a:srgbClr val="132B4D"/>
+          </a:solidFill>
+          <a:ln>
+            <a:noFill/>
+          </a:ln>
+        </p:spPr>
+        <p:style>
+          <a:lnRef idx="1">
+            <a:schemeClr val="accent1"/>
+          </a:lnRef>
+          <a:fillRef idx="3">
+            <a:schemeClr val="accent1"/>
+          </a:fillRef>
+          <a:effectRef idx="2">
+            <a:schemeClr val="accent1"/>
+          </a:effectRef>
+          <a:fontRef idx="minor">
+            <a:schemeClr val="lt1"/>
+          </a:fontRef>
+        </p:style>
+        <p:txBody>
+          <a:bodyPr rtlCol="0" anchor="ctr"/>
+          <a:lstStyle/>
+          <a:p>
+            <a:pPr algn="l"/>
+            <a:r>
+              <a:rPr sz="2400" b="1">
+                <a:solidFill>
+                  <a:srgbClr val="FFFFFF"/>
+                </a:solidFill>
+                <a:latin typeface="Microsoft YaHei"/>
+              </a:rPr>
+              <a:t>十一、汇报总结</a:t>
+            </a:r>
+          </a:p>
+          <a:p>
+            <a:r>
+              <a:rPr sz="1000">
+                <a:solidFill>
+                  <a:srgbClr val="DCE6F5"/>
+                </a:solidFill>
+                <a:latin typeface="Microsoft YaHei"/>
+              </a:rPr>
+              <a:t>选题聚焦明确、问题导向清晰、策略框架可落地</a:t>
+            </a:r>
+          </a:p>
+        </p:txBody>
+      </p:sp>
+      <p:sp>
+        <p:nvSpPr>
+          <p:cNvPr id="4" name="Rounded Rectangle 3"/>
+          <p:cNvSpPr/>
+          <p:nvPr/>
+        </p:nvSpPr>
+        <p:spPr>
+          <a:xfrm>
+            <a:off x="914400" y="1143000"/>
+            <a:ext cx="10332720" cy="1005840"/>
+          </a:xfrm>
+          <a:prstGeom prst="roundRect">
+            <a:avLst/>
+          </a:prstGeom>
+          <a:solidFill>
+            <a:srgbClr val="FFFFFF"/>
+          </a:solidFill>
+          <a:ln>
+            <a:solidFill>
+              <a:srgbClr val="D2DBE6"/>
+            </a:solidFill>
+          </a:ln>
+        </p:spPr>
+        <p:style>
+          <a:lnRef idx="1">
+            <a:schemeClr val="accent1"/>
+          </a:lnRef>
+          <a:fillRef idx="3">
+            <a:schemeClr val="accent1"/>
+          </a:fillRef>
+          <a:effectRef idx="2">
+            <a:schemeClr val="accent1"/>
+          </a:effectRef>
+          <a:fontRef idx="minor">
+            <a:schemeClr val="lt1"/>
+          </a:fontRef>
+        </p:style>
+        <p:txBody>
+          <a:bodyPr rtlCol="0" anchor="ctr"/>
+          <a:lstStyle/>
+          <a:p>
+            <a:pPr algn="ctr"/>
+          </a:p>
+        </p:txBody>
+      </p:sp>
+      <p:sp>
+        <p:nvSpPr>
+          <p:cNvPr id="5" name="TextBox 4"/>
+          <p:cNvSpPr txBox="1"/>
+          <p:nvPr/>
+        </p:nvSpPr>
+        <p:spPr>
+          <a:xfrm>
+            <a:off x="1234440" y="1481328"/>
+            <a:ext cx="9692640" cy="365760"/>
+          </a:xfrm>
+          <a:prstGeom prst="rect">
+            <a:avLst/>
+          </a:prstGeom>
+          <a:noFill/>
+        </p:spPr>
+        <p:txBody>
+          <a:bodyPr wrap="square" anchor="t">
+            <a:noAutofit/>
+          </a:bodyPr>
+          <a:lstStyle/>
+          <a:p>
+            <a:pPr algn="ctr"/>
+            <a:r>
+              <a:rPr sz="2200" b="1">
+                <a:solidFill>
+                  <a:srgbClr val="132B4D"/>
+                </a:solidFill>
+                <a:latin typeface="Microsoft YaHei"/>
+              </a:rPr>
+              <a:t>本研究将围绕"应用驱动、体验为先、软硬协同、双轮转化"展开系统研究。</a:t>
+            </a:r>
+          </a:p>
+        </p:txBody>
+      </p:sp>
+      <p:sp>
+        <p:nvSpPr>
+          <p:cNvPr id="6" name="Oval 5"/>
+          <p:cNvSpPr/>
+          <p:nvPr/>
+        </p:nvSpPr>
+        <p:spPr>
+          <a:xfrm>
+            <a:off x="1828800" y="2651760"/>
+            <a:ext cx="457200" cy="457200"/>
+          </a:xfrm>
+          <a:prstGeom prst="ellipse">
+            <a:avLst/>
+          </a:prstGeom>
+          <a:solidFill>
+            <a:srgbClr val="132B4D"/>
+          </a:solidFill>
+          <a:ln>
+            <a:noFill/>
+          </a:ln>
+        </p:spPr>
+        <p:style>
+          <a:lnRef idx="1">
+            <a:schemeClr val="accent1"/>
+          </a:lnRef>
+          <a:fillRef idx="3">
+            <a:schemeClr val="accent1"/>
+          </a:fillRef>
+          <a:effectRef idx="2">
+            <a:schemeClr val="accent1"/>
+          </a:effectRef>
+          <a:fontRef idx="minor">
+            <a:schemeClr val="lt1"/>
+          </a:fontRef>
+        </p:style>
+        <p:txBody>
+          <a:bodyPr rtlCol="0" anchor="ctr"/>
+          <a:lstStyle/>
+          <a:p>
+            <a:pPr algn="ctr"/>
+            <a:r>
+              <a:rPr sz="2000" b="1">
+                <a:solidFill>
+                  <a:srgbClr val="FFFFFF"/>
+                </a:solidFill>
+                <a:latin typeface="Microsoft YaHei"/>
+              </a:rPr>
+              <a:t>1</a:t>
+            </a:r>
+          </a:p>
+        </p:txBody>
+      </p:sp>
+      <p:sp>
+        <p:nvSpPr>
+          <p:cNvPr id="7" name="TextBox 6"/>
+          <p:cNvSpPr txBox="1"/>
+          <p:nvPr/>
+        </p:nvSpPr>
+        <p:spPr>
+          <a:xfrm>
+            <a:off x="2468880" y="2724912"/>
+            <a:ext cx="7315200" cy="274320"/>
+          </a:xfrm>
+          <a:prstGeom prst="rect">
+            <a:avLst/>
+          </a:prstGeom>
+          <a:noFill/>
+        </p:spPr>
+        <p:txBody>
+          <a:bodyPr wrap="square" anchor="t">
+            <a:noAutofit/>
+          </a:bodyPr>
+          <a:lstStyle/>
+          <a:p>
+            <a:pPr algn="l"/>
+            <a:r>
+              <a:rPr sz="1600" b="0">
+                <a:solidFill>
+                  <a:srgbClr val="1F2937"/>
+                </a:solidFill>
+                <a:latin typeface="Microsoft YaHei"/>
+              </a:rPr>
+              <a:t>点题：回答T公司如何把AI应用软件真正转化为商业价值。</a:t>
+            </a:r>
+          </a:p>
+        </p:txBody>
+      </p:sp>
+      <p:sp>
+        <p:nvSpPr>
+          <p:cNvPr id="8" name="Oval 7"/>
+          <p:cNvSpPr/>
+          <p:nvPr/>
+        </p:nvSpPr>
+        <p:spPr>
+          <a:xfrm>
+            <a:off x="1828800" y="3456432"/>
+            <a:ext cx="457200" cy="457200"/>
+          </a:xfrm>
+          <a:prstGeom prst="ellipse">
+            <a:avLst/>
+          </a:prstGeom>
+          <a:solidFill>
+            <a:srgbClr val="2B6CB0"/>
+          </a:solidFill>
+          <a:ln>
+            <a:noFill/>
+          </a:ln>
+        </p:spPr>
+        <p:style>
+          <a:lnRef idx="1">
+            <a:schemeClr val="accent1"/>
+          </a:lnRef>
+          <a:fillRef idx="3">
+            <a:schemeClr val="accent1"/>
+          </a:fillRef>
+          <a:effectRef idx="2">
+            <a:schemeClr val="accent1"/>
+          </a:effectRef>
+          <a:fontRef idx="minor">
+            <a:schemeClr val="lt1"/>
+          </a:fontRef>
+        </p:style>
+        <p:txBody>
+          <a:bodyPr rtlCol="0" anchor="ctr"/>
+          <a:lstStyle/>
+          <a:p>
+            <a:pPr algn="ctr"/>
+            <a:r>
+              <a:rPr sz="2000" b="1">
+                <a:solidFill>
+                  <a:srgbClr val="FFFFFF"/>
+                </a:solidFill>
+                <a:latin typeface="Microsoft YaHei"/>
+              </a:rPr>
+              <a:t>2</a:t>
+            </a:r>
+          </a:p>
+        </p:txBody>
+      </p:sp>
+      <p:sp>
+        <p:nvSpPr>
+          <p:cNvPr id="9" name="TextBox 8"/>
+          <p:cNvSpPr txBox="1"/>
+          <p:nvPr/>
+        </p:nvSpPr>
+        <p:spPr>
+          <a:xfrm>
+            <a:off x="2468880" y="3529584"/>
+            <a:ext cx="7315200" cy="274320"/>
+          </a:xfrm>
+          <a:prstGeom prst="rect">
+            <a:avLst/>
+          </a:prstGeom>
+          <a:noFill/>
+        </p:spPr>
+        <p:txBody>
+          <a:bodyPr wrap="square" anchor="t">
+            <a:noAutofit/>
+          </a:bodyPr>
+          <a:lstStyle/>
+          <a:p>
+            <a:pPr algn="l"/>
+            <a:r>
+              <a:rPr sz="1600" b="0">
+                <a:solidFill>
+                  <a:srgbClr val="1F2937"/>
+                </a:solidFill>
+                <a:latin typeface="Microsoft YaHei"/>
+              </a:rPr>
+              <a:t>聚焦：围绕"有算力、无应用"的典型问题展开诊断。</a:t>
+            </a:r>
+          </a:p>
+        </p:txBody>
+      </p:sp>
+      <p:sp>
+        <p:nvSpPr>
+          <p:cNvPr id="10" name="Oval 9"/>
+          <p:cNvSpPr/>
+          <p:nvPr/>
+        </p:nvSpPr>
+        <p:spPr>
+          <a:xfrm>
+            <a:off x="1828800" y="4261104"/>
+            <a:ext cx="457200" cy="457200"/>
+          </a:xfrm>
+          <a:prstGeom prst="ellipse">
+            <a:avLst/>
+          </a:prstGeom>
+          <a:solidFill>
+            <a:srgbClr val="1F7A8C"/>
+          </a:solidFill>
+          <a:ln>
+            <a:noFill/>
+          </a:ln>
+        </p:spPr>
+        <p:style>
+          <a:lnRef idx="1">
+            <a:schemeClr val="accent1"/>
+          </a:lnRef>
+          <a:fillRef idx="3">
+            <a:schemeClr val="accent1"/>
+          </a:fillRef>
+          <a:effectRef idx="2">
+            <a:schemeClr val="accent1"/>
+          </a:effectRef>
+          <a:fontRef idx="minor">
+            <a:schemeClr val="lt1"/>
+          </a:fontRef>
+        </p:style>
+        <p:txBody>
+          <a:bodyPr rtlCol="0" anchor="ctr"/>
+          <a:lstStyle/>
+          <a:p>
+            <a:pPr algn="ctr"/>
+            <a:r>
+              <a:rPr sz="2000" b="1">
+                <a:solidFill>
+                  <a:srgbClr val="FFFFFF"/>
+                </a:solidFill>
+                <a:latin typeface="Microsoft YaHei"/>
+              </a:rPr>
+              <a:t>3</a:t>
+            </a:r>
+          </a:p>
+        </p:txBody>
+      </p:sp>
+      <p:sp>
+        <p:nvSpPr>
+          <p:cNvPr id="11" name="TextBox 10"/>
+          <p:cNvSpPr txBox="1"/>
+          <p:nvPr/>
+        </p:nvSpPr>
+        <p:spPr>
+          <a:xfrm>
+            <a:off x="2468880" y="4334256"/>
+            <a:ext cx="7315200" cy="274320"/>
+          </a:xfrm>
+          <a:prstGeom prst="rect">
+            <a:avLst/>
+          </a:prstGeom>
+          <a:noFill/>
+        </p:spPr>
+        <p:txBody>
+          <a:bodyPr wrap="square" anchor="t">
+            <a:noAutofit/>
+          </a:bodyPr>
+          <a:lstStyle/>
+          <a:p>
+            <a:pPr algn="l"/>
+            <a:r>
+              <a:rPr sz="1600" b="0">
+                <a:solidFill>
+                  <a:srgbClr val="1F2937"/>
+                </a:solidFill>
+                <a:latin typeface="Microsoft YaHei"/>
+              </a:rPr>
+              <a:t>方案：构建"软件直接变现 + OEM集成拉动"双轮驱动体系。</a:t>
+            </a:r>
+          </a:p>
+        </p:txBody>
+      </p:sp>
+      <p:sp>
+        <p:nvSpPr>
+          <p:cNvPr id="12" name="Oval 11"/>
+          <p:cNvSpPr/>
+          <p:nvPr/>
+        </p:nvSpPr>
+        <p:spPr>
+          <a:xfrm>
+            <a:off x="1828800" y="5065776"/>
+            <a:ext cx="457200" cy="457200"/>
+          </a:xfrm>
+          <a:prstGeom prst="ellipse">
+            <a:avLst/>
+          </a:prstGeom>
+          <a:solidFill>
+            <a:srgbClr val="ED8936"/>
+          </a:solidFill>
+          <a:ln>
+            <a:noFill/>
+          </a:ln>
+        </p:spPr>
+        <p:style>
+          <a:lnRef idx="1">
+            <a:schemeClr val="accent1"/>
+          </a:lnRef>
+          <a:fillRef idx="3">
+            <a:schemeClr val="accent1"/>
+          </a:fillRef>
+          <a:effectRef idx="2">
+            <a:schemeClr val="accent1"/>
+          </a:effectRef>
+          <a:fontRef idx="minor">
+            <a:schemeClr val="lt1"/>
+          </a:fontRef>
+        </p:style>
+        <p:txBody>
+          <a:bodyPr rtlCol="0" anchor="ctr"/>
+          <a:lstStyle/>
+          <a:p>
+            <a:pPr algn="ctr"/>
+            <a:r>
+              <a:rPr sz="2000" b="1">
+                <a:solidFill>
+                  <a:srgbClr val="FFFFFF"/>
+                </a:solidFill>
+                <a:latin typeface="Microsoft YaHei"/>
+              </a:rPr>
+              <a:t>4</a:t>
+            </a:r>
+          </a:p>
+        </p:txBody>
+      </p:sp>
+      <p:sp>
+        <p:nvSpPr>
+          <p:cNvPr id="13" name="TextBox 12"/>
+          <p:cNvSpPr txBox="1"/>
+          <p:nvPr/>
+        </p:nvSpPr>
+        <p:spPr>
+          <a:xfrm>
+            <a:off x="2468880" y="5138928"/>
+            <a:ext cx="7315200" cy="274320"/>
+          </a:xfrm>
+          <a:prstGeom prst="rect">
+            <a:avLst/>
+          </a:prstGeom>
+          <a:noFill/>
+        </p:spPr>
+        <p:txBody>
+          <a:bodyPr wrap="square" anchor="t">
+            <a:noAutofit/>
+          </a:bodyPr>
+          <a:lstStyle/>
+          <a:p>
+            <a:pPr algn="l"/>
+            <a:r>
+              <a:rPr sz="1600" b="0">
+                <a:solidFill>
+                  <a:srgbClr val="1F2937"/>
+                </a:solidFill>
+                <a:latin typeface="Microsoft YaHei"/>
+              </a:rPr>
+              <a:t>目标：为T公司及同类中型AI企业提供可复制的转化路径。</a:t>
+            </a:r>
+          </a:p>
+        </p:txBody>
+      </p:sp>
+      <p:sp>
+        <p:nvSpPr>
+          <p:cNvPr id="14" name="Rounded Rectangle 13"/>
+          <p:cNvSpPr/>
+          <p:nvPr/>
+        </p:nvSpPr>
+        <p:spPr>
+          <a:xfrm>
+            <a:off x="4434840" y="5897880"/>
+            <a:ext cx="3337560" cy="438912"/>
+          </a:xfrm>
+          <a:prstGeom prst="roundRect">
+            <a:avLst/>
+          </a:prstGeom>
+          <a:solidFill>
+            <a:srgbClr val="132B4D"/>
+          </a:solidFill>
+          <a:ln>
+            <a:noFill/>
+          </a:ln>
+        </p:spPr>
+        <p:style>
+          <a:lnRef idx="1">
+            <a:schemeClr val="accent1"/>
+          </a:lnRef>
+          <a:fillRef idx="3">
+            <a:schemeClr val="accent1"/>
+          </a:fillRef>
+          <a:effectRef idx="2">
+            <a:schemeClr val="accent1"/>
+          </a:effectRef>
+          <a:fontRef idx="minor">
+            <a:schemeClr val="lt1"/>
+          </a:fontRef>
+        </p:style>
+        <p:txBody>
+          <a:bodyPr rtlCol="0" anchor="ctr"/>
+          <a:lstStyle/>
+          <a:p>
+            <a:pPr algn="ctr"/>
+            <a:r>
+              <a:rPr sz="1600" b="1">
+                <a:solidFill>
+                  <a:srgbClr val="FFFFFF"/>
+                </a:solidFill>
+                <a:latin typeface="Microsoft YaHei"/>
+              </a:rPr>
+              <a:t>感谢聆听  ·  请各位老师批评指正</a:t>
+            </a:r>
+          </a:p>
+        </p:txBody>
+      </p:sp>
+      <p:sp>
+        <p:nvSpPr>
+          <p:cNvPr id="15" name="TextBox 14"/>
+          <p:cNvSpPr txBox="1"/>
+          <p:nvPr/>
+        </p:nvSpPr>
+        <p:spPr>
+          <a:xfrm>
+            <a:off x="11521440" y="6446520"/>
+            <a:ext cx="411480" cy="219456"/>
+          </a:xfrm>
+          <a:prstGeom prst="rect">
+            <a:avLst/>
+          </a:prstGeom>
+          <a:noFill/>
+        </p:spPr>
+        <p:txBody>
+          <a:bodyPr wrap="none">
+            <a:spAutoFit/>
+          </a:bodyPr>
+          <a:lstStyle/>
+          <a:p>
+            <a:pPr algn="r"/>
+            <a:r>
+              <a:rPr sz="1000">
+                <a:solidFill>
+                  <a:srgbClr val="6B7280"/>
+                </a:solidFill>
+                <a:latin typeface="Microsoft YaHei"/>
+              </a:rPr>
+              <a:t>12</a:t>
             </a:r>
           </a:p>
         </p:txBody>
@@ -5652,7 +7559,6 @@
           </a:bodyPr>
           <a:lstStyle/>
           <a:p>
-            <a:pPr/>
             <a:r>
               <a:rPr sz="1200">
                 <a:solidFill>
@@ -5664,7 +7570,6 @@
             </a:r>
           </a:p>
           <a:p>
-            <a:pPr/>
             <a:r>
               <a:rPr sz="1200">
                 <a:solidFill>
@@ -5676,7 +7581,6 @@
             </a:r>
           </a:p>
           <a:p>
-            <a:pPr/>
             <a:r>
               <a:rPr sz="1200">
                 <a:solidFill>
@@ -5834,7 +7738,6 @@
           </a:bodyPr>
           <a:lstStyle/>
           <a:p>
-            <a:pPr/>
             <a:r>
               <a:rPr sz="1200">
                 <a:solidFill>
@@ -5846,7 +7749,6 @@
             </a:r>
           </a:p>
           <a:p>
-            <a:pPr/>
             <a:r>
               <a:rPr sz="1200">
                 <a:solidFill>
@@ -5858,7 +7760,6 @@
             </a:r>
           </a:p>
           <a:p>
-            <a:pPr/>
             <a:r>
               <a:rPr sz="1200">
                 <a:solidFill>
@@ -6665,7 +8566,6 @@
           </a:bodyPr>
           <a:lstStyle/>
           <a:p>
-            <a:pPr/>
             <a:r>
               <a:rPr sz="1300">
                 <a:solidFill>
@@ -6677,7 +8577,6 @@
             </a:r>
           </a:p>
           <a:p>
-            <a:pPr/>
             <a:r>
               <a:rPr sz="1300">
                 <a:solidFill>
@@ -6689,7 +8588,6 @@
             </a:r>
           </a:p>
           <a:p>
-            <a:pPr/>
             <a:r>
               <a:rPr sz="1300">
                 <a:solidFill>
@@ -6701,7 +8599,6 @@
             </a:r>
           </a:p>
           <a:p>
-            <a:pPr/>
             <a:r>
               <a:rPr sz="1300">
                 <a:solidFill>
@@ -6713,7 +8610,6 @@
             </a:r>
           </a:p>
           <a:p>
-            <a:pPr/>
             <a:r>
               <a:rPr sz="1300">
                 <a:solidFill>
@@ -6871,7 +8767,6 @@
           </a:bodyPr>
           <a:lstStyle/>
           <a:p>
-            <a:pPr/>
             <a:r>
               <a:rPr sz="1300">
                 <a:solidFill>
@@ -6883,7 +8778,6 @@
             </a:r>
           </a:p>
           <a:p>
-            <a:pPr/>
             <a:r>
               <a:rPr sz="1300">
                 <a:solidFill>
@@ -6895,7 +8789,6 @@
             </a:r>
           </a:p>
           <a:p>
-            <a:pPr/>
             <a:r>
               <a:rPr sz="1300">
                 <a:solidFill>
@@ -6907,7 +8800,6 @@
             </a:r>
           </a:p>
           <a:p>
-            <a:pPr/>
             <a:r>
               <a:rPr sz="1300">
                 <a:solidFill>
@@ -6919,7 +8811,6 @@
             </a:r>
           </a:p>
           <a:p>
-            <a:pPr/>
             <a:r>
               <a:rPr sz="1300">
                 <a:solidFill>
@@ -7316,7 +9207,6 @@
           </a:bodyPr>
           <a:lstStyle/>
           <a:p>
-            <a:pPr/>
             <a:r>
               <a:rPr sz="1200">
                 <a:solidFill>
@@ -7328,7 +9218,6 @@
             </a:r>
           </a:p>
           <a:p>
-            <a:pPr/>
             <a:r>
               <a:rPr sz="1200">
                 <a:solidFill>
@@ -7340,7 +9229,6 @@
             </a:r>
           </a:p>
           <a:p>
-            <a:pPr/>
             <a:r>
               <a:rPr sz="1200">
                 <a:solidFill>
@@ -7352,7 +9240,6 @@
             </a:r>
           </a:p>
           <a:p>
-            <a:pPr/>
             <a:r>
               <a:rPr sz="1200">
                 <a:solidFill>
@@ -7758,7 +9645,6 @@
           </a:bodyPr>
           <a:lstStyle/>
           <a:p>
-            <a:pPr/>
             <a:r>
               <a:rPr sz="1200">
                 <a:solidFill>
@@ -7770,7 +9656,6 @@
             </a:r>
           </a:p>
           <a:p>
-            <a:pPr/>
             <a:r>
               <a:rPr sz="1200">
                 <a:solidFill>
@@ -7782,7 +9667,6 @@
             </a:r>
           </a:p>
           <a:p>
-            <a:pPr/>
             <a:r>
               <a:rPr sz="1200">
                 <a:solidFill>
@@ -7794,7 +9678,6 @@
             </a:r>
           </a:p>
           <a:p>
-            <a:pPr/>
             <a:r>
               <a:rPr sz="1200">
                 <a:solidFill>
@@ -7952,7 +9835,6 @@
           </a:bodyPr>
           <a:lstStyle/>
           <a:p>
-            <a:pPr/>
             <a:r>
               <a:rPr sz="1200">
                 <a:solidFill>
@@ -7964,7 +9846,6 @@
             </a:r>
           </a:p>
           <a:p>
-            <a:pPr/>
             <a:r>
               <a:rPr sz="1200">
                 <a:solidFill>
@@ -7976,7 +9857,6 @@
             </a:r>
           </a:p>
           <a:p>
-            <a:pPr/>
             <a:r>
               <a:rPr sz="1200">
                 <a:solidFill>
@@ -7988,7 +9868,6 @@
             </a:r>
           </a:p>
           <a:p>
-            <a:pPr/>
             <a:r>
               <a:rPr sz="1200">
                 <a:solidFill>
@@ -8000,7 +9879,6 @@
             </a:r>
           </a:p>
           <a:p>
-            <a:pPr/>
             <a:r>
               <a:rPr sz="1200">
                 <a:solidFill>
@@ -11188,7 +13066,60 @@
       </p:sp>
       <p:sp>
         <p:nvSpPr>
-          <p:cNvPr id="6" name="TextBox 5"/>
+          <p:cNvPr id="6" name="Oval 5"/>
+          <p:cNvSpPr/>
+          <p:nvPr/>
+        </p:nvSpPr>
+        <p:spPr>
+          <a:xfrm>
+            <a:off x="7909560" y="1691640"/>
+            <a:ext cx="2331720" cy="2331720"/>
+          </a:xfrm>
+          <a:prstGeom prst="ellipse">
+            <a:avLst/>
+          </a:prstGeom>
+          <a:solidFill>
+            <a:srgbClr val="ED8936"/>
+          </a:solidFill>
+          <a:ln>
+            <a:noFill/>
+          </a:ln>
+        </p:spPr>
+        <p:style>
+          <a:lnRef idx="1">
+            <a:schemeClr val="accent1"/>
+          </a:lnRef>
+          <a:fillRef idx="3">
+            <a:schemeClr val="accent1"/>
+          </a:fillRef>
+          <a:effectRef idx="2">
+            <a:schemeClr val="accent1"/>
+          </a:effectRef>
+          <a:fontRef idx="minor">
+            <a:schemeClr val="lt1"/>
+          </a:fontRef>
+        </p:style>
+        <p:txBody>
+          <a:bodyPr rtlCol="0" anchor="ctr"/>
+          <a:lstStyle/>
+          <a:p>
+            <a:pPr algn="ctr"/>
+            <a:r>
+              <a:rPr sz="2200" b="1">
+                <a:solidFill>
+                  <a:srgbClr val="FFFFFF"/>
+                </a:solidFill>
+                <a:latin typeface="Microsoft YaHei"/>
+              </a:rPr>
+              <a:t>轮2
+OEM集成拉动</a:t>
+            </a:r>
+          </a:p>
+        </p:txBody>
+      </p:sp>
+      <p:sp>
+        <p:nvSpPr>
+          <p:cNvPr id="7" name="TextBox 6"/>
           <p:cNvSpPr txBox="1"/>
           <p:nvPr/>
         </p:nvSpPr>
@@ -11229,59 +13160,6 @@
                 <a:latin typeface="Microsoft YaHei"/>
               </a:rPr>
               <a:t>形成独立软件收入与现金流</a:t>
-            </a:r>
-          </a:p>
-        </p:txBody>
-      </p:sp>
-      <p:sp>
-        <p:nvSpPr>
-          <p:cNvPr id="7" name="Oval 6"/>
-          <p:cNvSpPr/>
-          <p:nvPr/>
-        </p:nvSpPr>
-        <p:spPr>
-          <a:xfrm>
-            <a:off x="7909560" y="1691640"/>
-            <a:ext cx="2331720" cy="2331720"/>
-          </a:xfrm>
-          <a:prstGeom prst="ellipse">
-            <a:avLst/>
-          </a:prstGeom>
-          <a:solidFill>
-            <a:srgbClr val="ED8936"/>
-          </a:solidFill>
-          <a:ln>
-            <a:noFill/>
-          </a:ln>
-        </p:spPr>
-        <p:style>
-          <a:lnRef idx="1">
-            <a:schemeClr val="accent1"/>
-          </a:lnRef>
-          <a:fillRef idx="3">
-            <a:schemeClr val="accent1"/>
-          </a:fillRef>
-          <a:effectRef idx="2">
-            <a:schemeClr val="accent1"/>
-          </a:effectRef>
-          <a:fontRef idx="minor">
-            <a:schemeClr val="lt1"/>
-          </a:fontRef>
-        </p:style>
-        <p:txBody>
-          <a:bodyPr rtlCol="0" anchor="ctr"/>
-          <a:lstStyle/>
-          <a:p>
-            <a:pPr algn="ctr"/>
-            <a:r>
-              <a:rPr sz="2200" b="1">
-                <a:solidFill>
-                  <a:srgbClr val="FFFFFF"/>
-                </a:solidFill>
-                <a:latin typeface="Microsoft YaHei"/>
-              </a:rPr>
-              <a:t>轮2
-OEM集成拉动</a:t>
             </a:r>
           </a:p>
         </p:txBody>
@@ -14063,7 +15941,6 @@
           </a:bodyPr>
           <a:lstStyle/>
           <a:p>
-            <a:pPr/>
             <a:r>
               <a:rPr sz="1200">
                 <a:solidFill>
@@ -14075,7 +15952,6 @@
             </a:r>
           </a:p>
           <a:p>
-            <a:pPr/>
             <a:r>
               <a:rPr sz="1200">
                 <a:solidFill>
@@ -14087,7 +15963,6 @@
             </a:r>
           </a:p>
           <a:p>
-            <a:pPr/>
             <a:r>
               <a:rPr sz="1200">
                 <a:solidFill>
@@ -14245,7 +16120,6 @@
           </a:bodyPr>
           <a:lstStyle/>
           <a:p>
-            <a:pPr/>
             <a:r>
               <a:rPr sz="1200">
                 <a:solidFill>
@@ -14257,7 +16131,6 @@
             </a:r>
           </a:p>
           <a:p>
-            <a:pPr/>
             <a:r>
               <a:rPr sz="1200">
                 <a:solidFill>
@@ -14269,7 +16142,6 @@
             </a:r>
           </a:p>
           <a:p>
-            <a:pPr/>
             <a:r>
               <a:rPr sz="1200">
                 <a:solidFill>

</xml_diff>